<commit_message>
Add Visual Gallery component with example slides and navigation
</commit_message>
<xml_diff>
--- a/test_new_components.pptx
+++ b/test_new_components.pptx
@@ -4531,42 +4531,7 @@
       </p:sp>
       <p:sp>
         <p:nvSpPr>
-          <p:cNvPr id="19" name="TextBox 18"/>
-          <p:cNvSpPr txBox="1"/>
-          <p:nvPr/>
-        </p:nvSpPr>
-        <p:spPr>
-          <a:xfrm>
-            <a:off x="640080" y="4389120"/>
-            <a:ext cx="3301898" cy="-182880"/>
-          </a:xfrm>
-          <a:prstGeom prst="rect">
-            <a:avLst/>
-          </a:prstGeom>
-          <a:noFill/>
-        </p:spPr>
-        <p:txBody>
-          <a:bodyPr wrap="square" lIns="0" tIns="0" rIns="0" bIns="0">
-            <a:spAutoFit/>
-          </a:bodyPr>
-          <a:lstStyle/>
-          <a:p>
-            <a:pPr algn="ctr"/>
-            <a:r>
-              <a:rPr sz="1100" b="0" i="0">
-                <a:solidFill>
-                  <a:srgbClr val="CBD5E1"/>
-                </a:solidFill>
-                <a:latin typeface="Calibri"/>
-              </a:rPr>
-              <a:t>First feature description</a:t>
-            </a:r>
-          </a:p>
-        </p:txBody>
-      </p:sp>
-      <p:sp>
-        <p:nvSpPr>
-          <p:cNvPr id="20" name="Rounded Rectangle 19"/>
+          <p:cNvPr id="19" name="Rounded Rectangle 18"/>
           <p:cNvSpPr/>
           <p:nvPr/>
         </p:nvSpPr>
@@ -4611,7 +4576,7 @@
       </p:sp>
       <p:sp>
         <p:nvSpPr>
-          <p:cNvPr id="21" name="Rounded Rectangle 20"/>
+          <p:cNvPr id="20" name="Rounded Rectangle 19"/>
           <p:cNvSpPr/>
           <p:nvPr/>
         </p:nvSpPr>
@@ -4656,7 +4621,7 @@
       </p:sp>
       <p:sp>
         <p:nvSpPr>
-          <p:cNvPr id="22" name="TextBox 21"/>
+          <p:cNvPr id="21" name="TextBox 20"/>
           <p:cNvSpPr txBox="1"/>
           <p:nvPr/>
         </p:nvSpPr>
@@ -4691,7 +4656,7 @@
       </p:sp>
       <p:sp>
         <p:nvSpPr>
-          <p:cNvPr id="23" name="TextBox 22"/>
+          <p:cNvPr id="22" name="TextBox 21"/>
           <p:cNvSpPr txBox="1"/>
           <p:nvPr/>
         </p:nvSpPr>
@@ -4726,42 +4691,7 @@
       </p:sp>
       <p:sp>
         <p:nvSpPr>
-          <p:cNvPr id="24" name="TextBox 23"/>
-          <p:cNvSpPr txBox="1"/>
-          <p:nvPr/>
-        </p:nvSpPr>
-        <p:spPr>
-          <a:xfrm>
-            <a:off x="4444898" y="4389120"/>
-            <a:ext cx="3301898" cy="-182880"/>
-          </a:xfrm>
-          <a:prstGeom prst="rect">
-            <a:avLst/>
-          </a:prstGeom>
-          <a:noFill/>
-        </p:spPr>
-        <p:txBody>
-          <a:bodyPr wrap="square" lIns="0" tIns="0" rIns="0" bIns="0">
-            <a:spAutoFit/>
-          </a:bodyPr>
-          <a:lstStyle/>
-          <a:p>
-            <a:pPr algn="ctr"/>
-            <a:r>
-              <a:rPr sz="1100" b="0" i="0">
-                <a:solidFill>
-                  <a:srgbClr val="CBD5E1"/>
-                </a:solidFill>
-                <a:latin typeface="Calibri"/>
-              </a:rPr>
-              <a:t>Second feature description</a:t>
-            </a:r>
-          </a:p>
-        </p:txBody>
-      </p:sp>
-      <p:sp>
-        <p:nvSpPr>
-          <p:cNvPr id="25" name="Rounded Rectangle 24"/>
+          <p:cNvPr id="23" name="Rounded Rectangle 22"/>
           <p:cNvSpPr/>
           <p:nvPr/>
         </p:nvSpPr>
@@ -4806,7 +4736,7 @@
       </p:sp>
       <p:sp>
         <p:nvSpPr>
-          <p:cNvPr id="26" name="Rounded Rectangle 25"/>
+          <p:cNvPr id="24" name="Rounded Rectangle 23"/>
           <p:cNvSpPr/>
           <p:nvPr/>
         </p:nvSpPr>
@@ -4851,7 +4781,7 @@
       </p:sp>
       <p:sp>
         <p:nvSpPr>
-          <p:cNvPr id="27" name="TextBox 26"/>
+          <p:cNvPr id="25" name="TextBox 24"/>
           <p:cNvSpPr txBox="1"/>
           <p:nvPr/>
         </p:nvSpPr>
@@ -4886,7 +4816,7 @@
       </p:sp>
       <p:sp>
         <p:nvSpPr>
-          <p:cNvPr id="28" name="TextBox 27"/>
+          <p:cNvPr id="26" name="TextBox 25"/>
           <p:cNvSpPr txBox="1"/>
           <p:nvPr/>
         </p:nvSpPr>
@@ -4915,41 +4845,6 @@
                 <a:latin typeface="Calibri"/>
               </a:rPr>
               <a:t>Feature 3</a:t>
-            </a:r>
-          </a:p>
-        </p:txBody>
-      </p:sp>
-      <p:sp>
-        <p:nvSpPr>
-          <p:cNvPr id="29" name="TextBox 28"/>
-          <p:cNvSpPr txBox="1"/>
-          <p:nvPr/>
-        </p:nvSpPr>
-        <p:spPr>
-          <a:xfrm>
-            <a:off x="8249716" y="4389120"/>
-            <a:ext cx="3301898" cy="-182880"/>
-          </a:xfrm>
-          <a:prstGeom prst="rect">
-            <a:avLst/>
-          </a:prstGeom>
-          <a:noFill/>
-        </p:spPr>
-        <p:txBody>
-          <a:bodyPr wrap="square" lIns="0" tIns="0" rIns="0" bIns="0">
-            <a:spAutoFit/>
-          </a:bodyPr>
-          <a:lstStyle/>
-          <a:p>
-            <a:pPr algn="ctr"/>
-            <a:r>
-              <a:rPr sz="1100" b="0" i="0">
-                <a:solidFill>
-                  <a:srgbClr val="CBD5E1"/>
-                </a:solidFill>
-                <a:latin typeface="Calibri"/>
-              </a:rPr>
-              <a:t>Third feature description</a:t>
             </a:r>
           </a:p>
         </p:txBody>

</xml_diff>